<commit_message>
docs: the demo video (GitHub release) linked from the deck, README, /judges and the footer; 'middle school' instead of Class 6-7 as the audience in the deck and on the landing page
</commit_message>
<xml_diff>
--- a/docs/pitch/GuruGraph_TeamX_T28_Round2.pptx
+++ b/docs/pitch/GuruGraph_TeamX_T28_Round2.pptx
@@ -822,7 +822,7 @@
           </a:p>
           <a:p>
             <a:r>
-              <a:t>"Our customer is the Class 6-8 maths teacher: budget private schools first, then government schools through the state. Karnataka alone has 19,105 private unaided schools, and only 8.2% of students there take coaching, so the fix has to happen in school. A per-student school licence; the AI costs Rs 3.64 per child per month, measured. It scales because the unit never changes: one child, one problem, one wrong step. A school view already rolls it up; a district is the same query."</a:t>
+              <a:t>"Our customer is the middle-school maths teacher: budget private schools first, then government schools through the state. Karnataka alone has 19,105 private unaided schools, and only 8.2% of students there take coaching, so the fix has to happen in school. A per-student school licence; the AI costs Rs 3.64 per child per month, measured. It scales because the unit never changes: one child, one problem, one wrong step. A school view already rolls it up; a district is the same query."</a:t>
             </a:r>
           </a:p>
           <a:p>
@@ -4105,7 +4105,7 @@
                 <a:ea typeface="Montserrat"/>
                 <a:cs typeface="Montserrat"/>
               </a:rPr>
-              <a:t>Marks Class 6–7 fraction homework from a phone photo, circles the exact wrong step, and gives the teacher tomorrow's 5‑minute re‑teach.</a:t>
+              <a:t>Marks middle-school fraction homework from a phone photo, circles the exact wrong step, and gives the teacher tomorrow's 5‑minute re‑teach.</a:t>
             </a:r>
           </a:p>
         </p:txBody>
@@ -7169,18 +7169,19 @@
                 <a:ea typeface="Montserrat"/>
                 <a:cs typeface="Montserrat"/>
               </a:rPr>
-              <a:t>▶  2-min demo video: </a:t>
-            </a:r>
-            <a:r>
-              <a:rPr sz="1500" b="1" i="0">
-                <a:solidFill>
-                  <a:srgbClr val="C0392B"/>
-                </a:solidFill>
-                <a:latin typeface="Montserrat"/>
-                <a:ea typeface="Montserrat"/>
-                <a:cs typeface="Montserrat"/>
-              </a:rPr>
-              <a:t>[add the link before submission]</a:t>
+              <a:t>▶  Demo video:  </a:t>
+            </a:r>
+            <a:r>
+              <a:rPr sz="1500" b="0" i="0" u="sng">
+                <a:solidFill>
+                  <a:srgbClr val="1D2B35"/>
+                </a:solidFill>
+                <a:latin typeface="Montserrat"/>
+                <a:ea typeface="Montserrat"/>
+                <a:cs typeface="Montserrat"/>
+                <a:hlinkClick r:id="rId8"/>
+              </a:rPr>
+              <a:t>github.com/Argonyx-26/T28-Team-X/releases</a:t>
             </a:r>
           </a:p>
           <a:p>
@@ -8762,7 +8763,7 @@
               </a:lnSpc>
             </a:pPr>
             <a:r>
-              <a:rPr sz="2500" b="0" i="0">
+              <a:rPr sz="2200" b="0" i="0">
                 <a:solidFill>
                   <a:srgbClr val="1D2B35"/>
                 </a:solidFill>
@@ -8770,7 +8771,7 @@
                 <a:ea typeface="Montserrat ExtraBold"/>
                 <a:cs typeface="Montserrat ExtraBold"/>
               </a:rPr>
-              <a:t>Class 6–8 maths teachers</a:t>
+              <a:t>Middle-school maths teachers</a:t>
             </a:r>
           </a:p>
         </p:txBody>
@@ -10272,7 +10273,7 @@
                 <a:ea typeface="Montserrat"/>
                 <a:cs typeface="Montserrat"/>
               </a:rPr>
-              <a:t>All Class 6–8 maths topics</a:t>
+              <a:t>All middle-school maths topics</a:t>
             </a:r>
           </a:p>
           <a:p>

</xml_diff>